<commit_message>
Rebuild 14 Harbor Court flyer + slide: fix WCAG contrast violations (green→navy on light surfaces)
</commit_message>
<xml_diff>
--- a/flyers/14-harbor-court.pptx
+++ b/flyers/14-harbor-court.pptx
@@ -3182,7 +3182,7 @@
         </p:nvSpPr>
         <p:spPr>
           <a:xfrm>
-            <a:off x="2286000" y="4648200"/>
+            <a:off x="2286000" y="4667250"/>
             <a:ext cx="1905000" cy="247650"/>
           </a:xfrm>
           <a:prstGeom prst="rect">
@@ -3198,7 +3198,7 @@
           <a:p>
             <a:pPr algn="ctr"/>
             <a:r>
-              <a:rPr sz="800" b="1" i="0">
+              <a:rPr sz="800" b="1">
                 <a:solidFill>
                   <a:srgbClr val="FFFFFF"/>
                 </a:solidFill>
@@ -3320,7 +3320,7 @@
           <a:p>
             <a:pPr algn="l"/>
             <a:r>
-              <a:rPr sz="800" b="1" i="0">
+              <a:rPr sz="800" b="1">
                 <a:solidFill>
                   <a:srgbClr val="01FFB7"/>
                 </a:solidFill>
@@ -3339,7 +3339,7 @@
         </p:nvSpPr>
         <p:spPr>
           <a:xfrm>
-            <a:off x="6934200" y="1447800"/>
+            <a:off x="6934200" y="1409700"/>
             <a:ext cx="8191500" cy="666750"/>
           </a:xfrm>
           <a:prstGeom prst="rect">
@@ -3355,7 +3355,7 @@
           <a:p>
             <a:pPr algn="l"/>
             <a:r>
-              <a:rPr sz="5200" b="1" i="0">
+              <a:rPr sz="5200" b="1">
                 <a:solidFill>
                   <a:srgbClr val="01133D"/>
                 </a:solidFill>
@@ -3374,7 +3374,7 @@
         </p:nvSpPr>
         <p:spPr>
           <a:xfrm>
-            <a:off x="6934200" y="2133600"/>
+            <a:off x="6934200" y="2095500"/>
             <a:ext cx="8191500" cy="666750"/>
           </a:xfrm>
           <a:prstGeom prst="rect">
@@ -3390,7 +3390,7 @@
           <a:p>
             <a:pPr algn="l"/>
             <a:r>
-              <a:rPr sz="5200" b="1" i="0">
+              <a:rPr sz="5200" b="1">
                 <a:solidFill>
                   <a:srgbClr val="01133D"/>
                 </a:solidFill>
@@ -3409,7 +3409,7 @@
         </p:nvSpPr>
         <p:spPr>
           <a:xfrm>
-            <a:off x="6934200" y="2857500"/>
+            <a:off x="6934200" y="2819400"/>
             <a:ext cx="6667500" cy="247650"/>
           </a:xfrm>
           <a:prstGeom prst="rect">
@@ -3425,7 +3425,7 @@
           <a:p>
             <a:pPr algn="l"/>
             <a:r>
-              <a:rPr sz="1100" b="1" i="0">
+              <a:rPr sz="1100" b="1">
                 <a:solidFill>
                   <a:srgbClr val="4C4DC3"/>
                 </a:solidFill>
@@ -3444,7 +3444,7 @@
         </p:nvSpPr>
         <p:spPr>
           <a:xfrm>
-            <a:off x="6934200" y="3276600"/>
+            <a:off x="6934200" y="3238500"/>
             <a:ext cx="1504950" cy="457200"/>
           </a:xfrm>
           <a:prstGeom prst="rect">
@@ -3460,7 +3460,7 @@
           <a:p>
             <a:pPr algn="l"/>
             <a:r>
-              <a:rPr sz="3600" b="1" i="0">
+              <a:rPr sz="3600" b="1">
                 <a:solidFill>
                   <a:srgbClr val="01133D"/>
                 </a:solidFill>
@@ -3479,7 +3479,7 @@
         </p:nvSpPr>
         <p:spPr>
           <a:xfrm>
-            <a:off x="6934200" y="3752850"/>
+            <a:off x="6934200" y="3714750"/>
             <a:ext cx="1504950" cy="190500"/>
           </a:xfrm>
           <a:prstGeom prst="rect">
@@ -3495,7 +3495,7 @@
           <a:p>
             <a:pPr algn="l"/>
             <a:r>
-              <a:rPr sz="800" b="1" i="0">
+              <a:rPr sz="800" b="1">
                 <a:solidFill>
                   <a:srgbClr val="4C4DC3"/>
                 </a:solidFill>
@@ -3514,7 +3514,7 @@
         </p:nvSpPr>
         <p:spPr>
           <a:xfrm>
-            <a:off x="8515350" y="3276600"/>
+            <a:off x="8515350" y="3238500"/>
             <a:ext cx="1504950" cy="457200"/>
           </a:xfrm>
           <a:prstGeom prst="rect">
@@ -3530,7 +3530,7 @@
           <a:p>
             <a:pPr algn="l"/>
             <a:r>
-              <a:rPr sz="3600" b="1" i="0">
+              <a:rPr sz="3600" b="1">
                 <a:solidFill>
                   <a:srgbClr val="01133D"/>
                 </a:solidFill>
@@ -3549,7 +3549,7 @@
         </p:nvSpPr>
         <p:spPr>
           <a:xfrm>
-            <a:off x="8515350" y="3752850"/>
+            <a:off x="8515350" y="3714750"/>
             <a:ext cx="1504950" cy="190500"/>
           </a:xfrm>
           <a:prstGeom prst="rect">
@@ -3565,7 +3565,7 @@
           <a:p>
             <a:pPr algn="l"/>
             <a:r>
-              <a:rPr sz="800" b="1" i="0">
+              <a:rPr sz="800" b="1">
                 <a:solidFill>
                   <a:srgbClr val="4C4DC3"/>
                 </a:solidFill>
@@ -3584,7 +3584,7 @@
         </p:nvSpPr>
         <p:spPr>
           <a:xfrm>
-            <a:off x="10096500" y="3276600"/>
+            <a:off x="10096500" y="3238500"/>
             <a:ext cx="1504950" cy="457200"/>
           </a:xfrm>
           <a:prstGeom prst="rect">
@@ -3600,7 +3600,7 @@
           <a:p>
             <a:pPr algn="l"/>
             <a:r>
-              <a:rPr sz="3600" b="1" i="0">
+              <a:rPr sz="3600" b="1">
                 <a:solidFill>
                   <a:srgbClr val="01133D"/>
                 </a:solidFill>
@@ -3619,7 +3619,7 @@
         </p:nvSpPr>
         <p:spPr>
           <a:xfrm>
-            <a:off x="10096500" y="3752850"/>
+            <a:off x="10096500" y="3714750"/>
             <a:ext cx="1504950" cy="190500"/>
           </a:xfrm>
           <a:prstGeom prst="rect">
@@ -3635,7 +3635,7 @@
           <a:p>
             <a:pPr algn="l"/>
             <a:r>
-              <a:rPr sz="800" b="1" i="0">
+              <a:rPr sz="800" b="1">
                 <a:solidFill>
                   <a:srgbClr val="4C4DC3"/>
                 </a:solidFill>
@@ -3654,7 +3654,7 @@
         </p:nvSpPr>
         <p:spPr>
           <a:xfrm>
-            <a:off x="11677650" y="3276600"/>
+            <a:off x="11677650" y="3238500"/>
             <a:ext cx="1504950" cy="457200"/>
           </a:xfrm>
           <a:prstGeom prst="rect">
@@ -3670,7 +3670,7 @@
           <a:p>
             <a:pPr algn="l"/>
             <a:r>
-              <a:rPr sz="3600" b="1" i="0">
+              <a:rPr sz="3600" b="1">
                 <a:solidFill>
                   <a:srgbClr val="01133D"/>
                 </a:solidFill>
@@ -3689,7 +3689,7 @@
         </p:nvSpPr>
         <p:spPr>
           <a:xfrm>
-            <a:off x="11677650" y="3752850"/>
+            <a:off x="11677650" y="3714750"/>
             <a:ext cx="1504950" cy="190500"/>
           </a:xfrm>
           <a:prstGeom prst="rect">
@@ -3705,7 +3705,7 @@
           <a:p>
             <a:pPr algn="l"/>
             <a:r>
-              <a:rPr sz="800" b="1" i="0">
+              <a:rPr sz="800" b="1">
                 <a:solidFill>
                   <a:srgbClr val="4C4DC3"/>
                 </a:solidFill>
@@ -3724,7 +3724,7 @@
         </p:nvSpPr>
         <p:spPr>
           <a:xfrm>
-            <a:off x="6934200" y="4038600"/>
+            <a:off x="6934200" y="4000500"/>
             <a:ext cx="8001000" cy="9525"/>
           </a:xfrm>
           <a:prstGeom prst="rect">
@@ -3761,128 +3761,23 @@
       </p:sp>
       <p:sp>
         <p:nvSpPr>
-          <p:cNvPr id="20" name="TextBox 19"/>
-          <p:cNvSpPr txBox="1"/>
+          <p:cNvPr id="20" name="Rectangle 19"/>
+          <p:cNvSpPr/>
           <p:nvPr/>
         </p:nvSpPr>
         <p:spPr>
           <a:xfrm>
-            <a:off x="6934200" y="4305300"/>
-            <a:ext cx="228600" cy="323850"/>
+            <a:off x="6934200" y="4686300"/>
+            <a:ext cx="1866900" cy="28575"/>
           </a:xfrm>
           <a:prstGeom prst="rect">
             <a:avLst/>
           </a:prstGeom>
-          <a:noFill/>
-        </p:spPr>
-        <p:txBody>
-          <a:bodyPr wrap="none">
-            <a:spAutoFit/>
-          </a:bodyPr>
-          <a:lstStyle/>
-          <a:p>
-            <a:pPr algn="l"/>
-            <a:r>
-              <a:rPr sz="1600" b="1" i="0">
-                <a:solidFill>
-                  <a:srgbClr val="01FFB7"/>
-                </a:solidFill>
-                <a:latin typeface="Arial"/>
-              </a:rPr>
-              <a:t>$</a:t>
-            </a:r>
-          </a:p>
-        </p:txBody>
-      </p:sp>
-      <p:sp>
-        <p:nvSpPr>
-          <p:cNvPr id="21" name="TextBox 20"/>
-          <p:cNvSpPr txBox="1"/>
-          <p:nvPr/>
-        </p:nvSpPr>
-        <p:spPr>
-          <a:xfrm>
-            <a:off x="7181850" y="4210050"/>
-            <a:ext cx="1714500" cy="495300"/>
-          </a:xfrm>
-          <a:prstGeom prst="rect">
-            <a:avLst/>
-          </a:prstGeom>
-          <a:noFill/>
-        </p:spPr>
-        <p:txBody>
-          <a:bodyPr wrap="none">
-            <a:spAutoFit/>
-          </a:bodyPr>
-          <a:lstStyle/>
-          <a:p>
-            <a:pPr algn="l"/>
-            <a:r>
-              <a:rPr sz="4200" b="1" i="0">
-                <a:solidFill>
-                  <a:srgbClr val="01FFB7"/>
-                </a:solidFill>
-                <a:latin typeface="Bookman Old Style"/>
-              </a:rPr>
-              <a:t>3,600</a:t>
-            </a:r>
-          </a:p>
-        </p:txBody>
-      </p:sp>
-      <p:sp>
-        <p:nvSpPr>
-          <p:cNvPr id="22" name="TextBox 21"/>
-          <p:cNvSpPr txBox="1"/>
-          <p:nvPr/>
-        </p:nvSpPr>
-        <p:spPr>
-          <a:xfrm>
-            <a:off x="8953500" y="4381500"/>
-            <a:ext cx="1333500" cy="228600"/>
-          </a:xfrm>
-          <a:prstGeom prst="rect">
-            <a:avLst/>
-          </a:prstGeom>
-          <a:noFill/>
-        </p:spPr>
-        <p:txBody>
-          <a:bodyPr wrap="none">
-            <a:spAutoFit/>
-          </a:bodyPr>
-          <a:lstStyle/>
-          <a:p>
-            <a:pPr algn="l"/>
-            <a:r>
-              <a:rPr sz="1000" b="1" i="0">
-                <a:solidFill>
-                  <a:srgbClr val="8084A0"/>
-                </a:solidFill>
-                <a:latin typeface="Arial"/>
-              </a:rPr>
-              <a:t>PER MONTH</a:t>
-            </a:r>
-          </a:p>
-        </p:txBody>
-      </p:sp>
-      <p:sp>
-        <p:nvSpPr>
-          <p:cNvPr id="23" name="Rectangle 22"/>
-          <p:cNvSpPr/>
-          <p:nvPr/>
-        </p:nvSpPr>
-        <p:spPr>
-          <a:xfrm>
-            <a:off x="10648950" y="4286250"/>
-            <a:ext cx="2286000" cy="342900"/>
-          </a:xfrm>
-          <a:prstGeom prst="rect">
-            <a:avLst/>
-          </a:prstGeom>
-          <a:noFill/>
-          <a:ln w="9525">
-            <a:solidFill>
-              <a:srgbClr val="01FFB7"/>
-            </a:solidFill>
+          <a:solidFill>
+            <a:srgbClr val="01FFB7"/>
+          </a:solidFill>
+          <a:ln>
+            <a:noFill/>
           </a:ln>
         </p:spPr>
         <p:style>
@@ -3909,14 +3804,14 @@
       </p:sp>
       <p:sp>
         <p:nvSpPr>
-          <p:cNvPr id="24" name="TextBox 23"/>
+          <p:cNvPr id="21" name="TextBox 20"/>
           <p:cNvSpPr txBox="1"/>
           <p:nvPr/>
         </p:nvSpPr>
         <p:spPr>
           <a:xfrm>
-            <a:off x="10782300" y="4381500"/>
-            <a:ext cx="2076450" cy="190500"/>
+            <a:off x="6934200" y="4267200"/>
+            <a:ext cx="228600" cy="342900"/>
           </a:xfrm>
           <a:prstGeom prst="rect">
             <a:avLst/>
@@ -3931,27 +3826,27 @@
           <a:p>
             <a:pPr algn="l"/>
             <a:r>
-              <a:rPr sz="750" b="1" i="0">
-                <a:solidFill>
-                  <a:srgbClr val="01FFB7"/>
+              <a:rPr sz="1600" b="1">
+                <a:solidFill>
+                  <a:srgbClr val="01133D"/>
                 </a:solidFill>
                 <a:latin typeface="Arial"/>
               </a:rPr>
-              <a:t>● AVAILABLE AUG 15, 2026</a:t>
-            </a:r>
-          </a:p>
-        </p:txBody>
-      </p:sp>
-      <p:sp>
-        <p:nvSpPr>
-          <p:cNvPr id="25" name="TextBox 24"/>
+              <a:t>$</a:t>
+            </a:r>
+          </a:p>
+        </p:txBody>
+      </p:sp>
+      <p:sp>
+        <p:nvSpPr>
+          <p:cNvPr id="22" name="TextBox 21"/>
           <p:cNvSpPr txBox="1"/>
           <p:nvPr/>
         </p:nvSpPr>
         <p:spPr>
           <a:xfrm>
-            <a:off x="6934200" y="4819650"/>
-            <a:ext cx="8001000" cy="171450"/>
+            <a:off x="7181850" y="4171950"/>
+            <a:ext cx="1866900" cy="514350"/>
           </a:xfrm>
           <a:prstGeom prst="rect">
             <a:avLst/>
@@ -3966,27 +3861,27 @@
           <a:p>
             <a:pPr algn="l"/>
             <a:r>
-              <a:rPr sz="800" b="1" i="0">
-                <a:solidFill>
-                  <a:srgbClr val="4C4DC3"/>
-                </a:solidFill>
-                <a:latin typeface="Arial"/>
+              <a:rPr sz="4200" b="1">
+                <a:solidFill>
+                  <a:srgbClr val="01133D"/>
+                </a:solidFill>
+                <a:latin typeface="Bookman Old Style"/>
               </a:rPr>
-              <a:t>ABOUT THIS HOME</a:t>
-            </a:r>
-          </a:p>
-        </p:txBody>
-      </p:sp>
-      <p:sp>
-        <p:nvSpPr>
-          <p:cNvPr id="26" name="TextBox 25"/>
+              <a:t>3,600</a:t>
+            </a:r>
+          </a:p>
+        </p:txBody>
+      </p:sp>
+      <p:sp>
+        <p:nvSpPr>
+          <p:cNvPr id="23" name="TextBox 22"/>
           <p:cNvSpPr txBox="1"/>
           <p:nvPr/>
         </p:nvSpPr>
         <p:spPr>
           <a:xfrm>
-            <a:off x="6934200" y="5029200"/>
-            <a:ext cx="8001000" cy="552450"/>
+            <a:off x="9105900" y="4343400"/>
+            <a:ext cx="1333500" cy="228600"/>
           </a:xfrm>
           <a:prstGeom prst="rect">
             <a:avLst/>
@@ -3994,43 +3889,43 @@
           <a:noFill/>
         </p:spPr>
         <p:txBody>
-          <a:bodyPr wrap="square">
+          <a:bodyPr wrap="none">
             <a:spAutoFit/>
           </a:bodyPr>
           <a:lstStyle/>
           <a:p>
             <a:pPr algn="l"/>
             <a:r>
-              <a:rPr sz="950" b="0">
-                <a:solidFill>
-                  <a:srgbClr val="01133D"/>
+              <a:rPr sz="1000" b="1">
+                <a:solidFill>
+                  <a:srgbClr val="607080"/>
                 </a:solidFill>
                 <a:latin typeface="Arial"/>
               </a:rPr>
-              <a:t>Stunning waterfront residence with panoramic Hudson River views. Renovated kitchen, spa-inspired baths, in-unit laundry, central air, and a private outdoor terrace. Steps from the Grove Street PATH station.</a:t>
-            </a:r>
-          </a:p>
-        </p:txBody>
-      </p:sp>
-      <p:sp>
-        <p:nvSpPr>
-          <p:cNvPr id="27" name="Rectangle 26"/>
+              <a:t>PER MONTH</a:t>
+            </a:r>
+          </a:p>
+        </p:txBody>
+      </p:sp>
+      <p:sp>
+        <p:nvSpPr>
+          <p:cNvPr id="24" name="Rectangle 23"/>
           <p:cNvSpPr/>
           <p:nvPr/>
         </p:nvSpPr>
         <p:spPr>
           <a:xfrm>
-            <a:off x="6477000" y="8572500"/>
-            <a:ext cx="11811000" cy="1714500"/>
+            <a:off x="10648950" y="4248150"/>
+            <a:ext cx="2362200" cy="361950"/>
           </a:xfrm>
           <a:prstGeom prst="rect">
             <a:avLst/>
           </a:prstGeom>
-          <a:solidFill>
-            <a:srgbClr val="01133D"/>
-          </a:solidFill>
-          <a:ln>
-            <a:noFill/>
+          <a:noFill/>
+          <a:ln w="9525">
+            <a:solidFill>
+              <a:srgbClr val="01FFB7"/>
+            </a:solidFill>
           </a:ln>
         </p:spPr>
         <p:style>
@@ -4057,16 +3952,16 @@
       </p:sp>
       <p:sp>
         <p:nvSpPr>
-          <p:cNvPr id="28" name="Rectangle 27"/>
+          <p:cNvPr id="25" name="Oval 24"/>
           <p:cNvSpPr/>
           <p:nvPr/>
         </p:nvSpPr>
         <p:spPr>
           <a:xfrm>
-            <a:off x="6477000" y="8572500"/>
-            <a:ext cx="11811000" cy="19050"/>
-          </a:xfrm>
-          <a:prstGeom prst="rect">
+            <a:off x="10763250" y="4391025"/>
+            <a:ext cx="76200" cy="76200"/>
+          </a:xfrm>
+          <a:prstGeom prst="ellipse">
             <a:avLst/>
           </a:prstGeom>
           <a:solidFill>
@@ -4100,14 +3995,14 @@
       </p:sp>
       <p:sp>
         <p:nvSpPr>
-          <p:cNvPr id="29" name="TextBox 28"/>
+          <p:cNvPr id="26" name="TextBox 25"/>
           <p:cNvSpPr txBox="1"/>
           <p:nvPr/>
         </p:nvSpPr>
         <p:spPr>
           <a:xfrm>
-            <a:off x="6934200" y="8763000"/>
-            <a:ext cx="1905000" cy="171450"/>
+            <a:off x="10896600" y="4343400"/>
+            <a:ext cx="2038350" cy="190500"/>
           </a:xfrm>
           <a:prstGeom prst="rect">
             <a:avLst/>
@@ -4122,27 +4017,27 @@
           <a:p>
             <a:pPr algn="l"/>
             <a:r>
-              <a:rPr sz="700" b="1" i="0">
-                <a:solidFill>
-                  <a:srgbClr val="97B9FF"/>
+              <a:rPr sz="750" b="1">
+                <a:solidFill>
+                  <a:srgbClr val="01133D"/>
                 </a:solidFill>
                 <a:latin typeface="Arial"/>
               </a:rPr>
-              <a:t>LEASING CONTACT</a:t>
-            </a:r>
-          </a:p>
-        </p:txBody>
-      </p:sp>
-      <p:sp>
-        <p:nvSpPr>
-          <p:cNvPr id="30" name="TextBox 29"/>
+              <a:t>AVAILABLE AUG 15, 2026</a:t>
+            </a:r>
+          </a:p>
+        </p:txBody>
+      </p:sp>
+      <p:sp>
+        <p:nvSpPr>
+          <p:cNvPr id="27" name="TextBox 26"/>
           <p:cNvSpPr txBox="1"/>
           <p:nvPr/>
         </p:nvSpPr>
         <p:spPr>
           <a:xfrm>
-            <a:off x="6934200" y="8972550"/>
-            <a:ext cx="2476500" cy="304800"/>
+            <a:off x="6934200" y="4800600"/>
+            <a:ext cx="8001000" cy="171450"/>
           </a:xfrm>
           <a:prstGeom prst="rect">
             <a:avLst/>
@@ -4157,27 +4052,27 @@
           <a:p>
             <a:pPr algn="l"/>
             <a:r>
-              <a:rPr sz="2000" b="0" i="0">
-                <a:solidFill>
-                  <a:srgbClr val="FFFFFF"/>
-                </a:solidFill>
-                <a:latin typeface="Bookman Old Style"/>
+              <a:rPr sz="800" b="1">
+                <a:solidFill>
+                  <a:srgbClr val="4C4DC3"/>
+                </a:solidFill>
+                <a:latin typeface="Arial"/>
               </a:rPr>
-              <a:t>Marcus Levy</a:t>
-            </a:r>
-          </a:p>
-        </p:txBody>
-      </p:sp>
-      <p:sp>
-        <p:nvSpPr>
-          <p:cNvPr id="31" name="TextBox 30"/>
+              <a:t>ABOUT THIS HOME</a:t>
+            </a:r>
+          </a:p>
+        </p:txBody>
+      </p:sp>
+      <p:sp>
+        <p:nvSpPr>
+          <p:cNvPr id="28" name="TextBox 27"/>
           <p:cNvSpPr txBox="1"/>
           <p:nvPr/>
         </p:nvSpPr>
         <p:spPr>
           <a:xfrm>
-            <a:off x="9601200" y="8763000"/>
-            <a:ext cx="1524000" cy="171450"/>
+            <a:off x="6934200" y="5010150"/>
+            <a:ext cx="8001000" cy="571500"/>
           </a:xfrm>
           <a:prstGeom prst="rect">
             <a:avLst/>
@@ -4185,34 +4080,120 @@
           <a:noFill/>
         </p:spPr>
         <p:txBody>
-          <a:bodyPr wrap="none">
+          <a:bodyPr wrap="square">
             <a:spAutoFit/>
           </a:bodyPr>
           <a:lstStyle/>
           <a:p>
             <a:pPr algn="l"/>
             <a:r>
-              <a:rPr sz="700" b="1" i="0">
-                <a:solidFill>
-                  <a:srgbClr val="97B9FF"/>
+              <a:rPr sz="950" b="0">
+                <a:solidFill>
+                  <a:srgbClr val="01133D"/>
                 </a:solidFill>
                 <a:latin typeface="Arial"/>
               </a:rPr>
-              <a:t>PHONE</a:t>
-            </a:r>
-          </a:p>
-        </p:txBody>
-      </p:sp>
-      <p:sp>
-        <p:nvSpPr>
-          <p:cNvPr id="32" name="TextBox 31"/>
+              <a:t>Stunning waterfront residence with panoramic Hudson River views. Renovated kitchen, spa-inspired baths, in-unit laundry, central air, and a private outdoor terrace. Steps from the Grove Street PATH station.</a:t>
+            </a:r>
+          </a:p>
+        </p:txBody>
+      </p:sp>
+      <p:sp>
+        <p:nvSpPr>
+          <p:cNvPr id="29" name="Rectangle 28"/>
+          <p:cNvSpPr/>
+          <p:nvPr/>
+        </p:nvSpPr>
+        <p:spPr>
+          <a:xfrm>
+            <a:off x="6477000" y="8572500"/>
+            <a:ext cx="11811000" cy="1714500"/>
+          </a:xfrm>
+          <a:prstGeom prst="rect">
+            <a:avLst/>
+          </a:prstGeom>
+          <a:solidFill>
+            <a:srgbClr val="01133D"/>
+          </a:solidFill>
+          <a:ln>
+            <a:noFill/>
+          </a:ln>
+        </p:spPr>
+        <p:style>
+          <a:lnRef idx="1">
+            <a:schemeClr val="accent1"/>
+          </a:lnRef>
+          <a:fillRef idx="3">
+            <a:schemeClr val="accent1"/>
+          </a:fillRef>
+          <a:effectRef idx="2">
+            <a:schemeClr val="accent1"/>
+          </a:effectRef>
+          <a:fontRef idx="minor">
+            <a:schemeClr val="lt1"/>
+          </a:fontRef>
+        </p:style>
+        <p:txBody>
+          <a:bodyPr rtlCol="0" anchor="ctr"/>
+          <a:lstStyle/>
+          <a:p>
+            <a:pPr algn="ctr"/>
+          </a:p>
+        </p:txBody>
+      </p:sp>
+      <p:sp>
+        <p:nvSpPr>
+          <p:cNvPr id="30" name="Rectangle 29"/>
+          <p:cNvSpPr/>
+          <p:nvPr/>
+        </p:nvSpPr>
+        <p:spPr>
+          <a:xfrm>
+            <a:off x="6477000" y="8572500"/>
+            <a:ext cx="11811000" cy="19050"/>
+          </a:xfrm>
+          <a:prstGeom prst="rect">
+            <a:avLst/>
+          </a:prstGeom>
+          <a:solidFill>
+            <a:srgbClr val="01FFB7"/>
+          </a:solidFill>
+          <a:ln>
+            <a:noFill/>
+          </a:ln>
+        </p:spPr>
+        <p:style>
+          <a:lnRef idx="1">
+            <a:schemeClr val="accent1"/>
+          </a:lnRef>
+          <a:fillRef idx="3">
+            <a:schemeClr val="accent1"/>
+          </a:fillRef>
+          <a:effectRef idx="2">
+            <a:schemeClr val="accent1"/>
+          </a:effectRef>
+          <a:fontRef idx="minor">
+            <a:schemeClr val="lt1"/>
+          </a:fontRef>
+        </p:style>
+        <p:txBody>
+          <a:bodyPr rtlCol="0" anchor="ctr"/>
+          <a:lstStyle/>
+          <a:p>
+            <a:pPr algn="ctr"/>
+          </a:p>
+        </p:txBody>
+      </p:sp>
+      <p:sp>
+        <p:nvSpPr>
+          <p:cNvPr id="31" name="TextBox 30"/>
           <p:cNvSpPr txBox="1"/>
           <p:nvPr/>
         </p:nvSpPr>
         <p:spPr>
           <a:xfrm>
-            <a:off x="9601200" y="8972550"/>
-            <a:ext cx="1905000" cy="247650"/>
+            <a:off x="6934200" y="8763000"/>
+            <a:ext cx="1905000" cy="171450"/>
           </a:xfrm>
           <a:prstGeom prst="rect">
             <a:avLst/>
@@ -4227,27 +4208,27 @@
           <a:p>
             <a:pPr algn="l"/>
             <a:r>
-              <a:rPr sz="1300" b="0" i="0">
-                <a:solidFill>
-                  <a:srgbClr val="FFFFFF"/>
+              <a:rPr sz="700" b="1">
+                <a:solidFill>
+                  <a:srgbClr val="97B9FF"/>
                 </a:solidFill>
                 <a:latin typeface="Arial"/>
               </a:rPr>
-              <a:t>(212) 555-0291</a:t>
-            </a:r>
-          </a:p>
-        </p:txBody>
-      </p:sp>
-      <p:sp>
-        <p:nvSpPr>
-          <p:cNvPr id="33" name="TextBox 32"/>
+              <a:t>LEASING CONTACT</a:t>
+            </a:r>
+          </a:p>
+        </p:txBody>
+      </p:sp>
+      <p:sp>
+        <p:nvSpPr>
+          <p:cNvPr id="32" name="TextBox 31"/>
           <p:cNvSpPr txBox="1"/>
           <p:nvPr/>
         </p:nvSpPr>
         <p:spPr>
           <a:xfrm>
-            <a:off x="11601450" y="8763000"/>
-            <a:ext cx="1714500" cy="171450"/>
+            <a:off x="6934200" y="8972550"/>
+            <a:ext cx="2476500" cy="304800"/>
           </a:xfrm>
           <a:prstGeom prst="rect">
             <a:avLst/>
@@ -4262,27 +4243,27 @@
           <a:p>
             <a:pPr algn="l"/>
             <a:r>
-              <a:rPr sz="700" b="1" i="0">
-                <a:solidFill>
-                  <a:srgbClr val="97B9FF"/>
-                </a:solidFill>
-                <a:latin typeface="Arial"/>
+              <a:rPr sz="2000" b="0">
+                <a:solidFill>
+                  <a:srgbClr val="FFFFFF"/>
+                </a:solidFill>
+                <a:latin typeface="Bookman Old Style"/>
               </a:rPr>
-              <a:t>EMAIL</a:t>
-            </a:r>
-          </a:p>
-        </p:txBody>
-      </p:sp>
-      <p:sp>
-        <p:nvSpPr>
-          <p:cNvPr id="34" name="TextBox 33"/>
+              <a:t>Marcus Levy</a:t>
+            </a:r>
+          </a:p>
+        </p:txBody>
+      </p:sp>
+      <p:sp>
+        <p:nvSpPr>
+          <p:cNvPr id="33" name="TextBox 32"/>
           <p:cNvSpPr txBox="1"/>
           <p:nvPr/>
         </p:nvSpPr>
         <p:spPr>
           <a:xfrm>
-            <a:off x="11601450" y="8972550"/>
-            <a:ext cx="4000500" cy="247650"/>
+            <a:off x="9601200" y="8763000"/>
+            <a:ext cx="1524000" cy="171450"/>
           </a:xfrm>
           <a:prstGeom prst="rect">
             <a:avLst/>
@@ -4297,27 +4278,27 @@
           <a:p>
             <a:pPr algn="l"/>
             <a:r>
-              <a:rPr sz="1300" b="0" i="0">
-                <a:solidFill>
-                  <a:srgbClr val="FFFFFF"/>
+              <a:rPr sz="700" b="1">
+                <a:solidFill>
+                  <a:srgbClr val="97B9FF"/>
                 </a:solidFill>
                 <a:latin typeface="Arial"/>
               </a:rPr>
-              <a:t>leasing@levylegacygroup.com</a:t>
-            </a:r>
-          </a:p>
-        </p:txBody>
-      </p:sp>
-      <p:sp>
-        <p:nvSpPr>
-          <p:cNvPr id="35" name="TextBox 34"/>
+              <a:t>PHONE</a:t>
+            </a:r>
+          </a:p>
+        </p:txBody>
+      </p:sp>
+      <p:sp>
+        <p:nvSpPr>
+          <p:cNvPr id="34" name="TextBox 33"/>
           <p:cNvSpPr txBox="1"/>
           <p:nvPr/>
         </p:nvSpPr>
         <p:spPr>
           <a:xfrm>
-            <a:off x="6934200" y="9886950"/>
-            <a:ext cx="7620000" cy="171450"/>
+            <a:off x="9601200" y="8972550"/>
+            <a:ext cx="1905000" cy="247650"/>
           </a:xfrm>
           <a:prstGeom prst="rect">
             <a:avLst/>
@@ -4332,7 +4313,112 @@
           <a:p>
             <a:pPr algn="l"/>
             <a:r>
-              <a:rPr sz="650" b="0" i="0">
+              <a:rPr sz="1300" b="0">
+                <a:solidFill>
+                  <a:srgbClr val="FFFFFF"/>
+                </a:solidFill>
+                <a:latin typeface="Arial"/>
+              </a:rPr>
+              <a:t>(212) 555-0291</a:t>
+            </a:r>
+          </a:p>
+        </p:txBody>
+      </p:sp>
+      <p:sp>
+        <p:nvSpPr>
+          <p:cNvPr id="35" name="TextBox 34"/>
+          <p:cNvSpPr txBox="1"/>
+          <p:nvPr/>
+        </p:nvSpPr>
+        <p:spPr>
+          <a:xfrm>
+            <a:off x="11601450" y="8763000"/>
+            <a:ext cx="1714500" cy="171450"/>
+          </a:xfrm>
+          <a:prstGeom prst="rect">
+            <a:avLst/>
+          </a:prstGeom>
+          <a:noFill/>
+        </p:spPr>
+        <p:txBody>
+          <a:bodyPr wrap="none">
+            <a:spAutoFit/>
+          </a:bodyPr>
+          <a:lstStyle/>
+          <a:p>
+            <a:pPr algn="l"/>
+            <a:r>
+              <a:rPr sz="700" b="1">
+                <a:solidFill>
+                  <a:srgbClr val="97B9FF"/>
+                </a:solidFill>
+                <a:latin typeface="Arial"/>
+              </a:rPr>
+              <a:t>EMAIL</a:t>
+            </a:r>
+          </a:p>
+        </p:txBody>
+      </p:sp>
+      <p:sp>
+        <p:nvSpPr>
+          <p:cNvPr id="36" name="TextBox 35"/>
+          <p:cNvSpPr txBox="1"/>
+          <p:nvPr/>
+        </p:nvSpPr>
+        <p:spPr>
+          <a:xfrm>
+            <a:off x="11601450" y="8972550"/>
+            <a:ext cx="4000500" cy="247650"/>
+          </a:xfrm>
+          <a:prstGeom prst="rect">
+            <a:avLst/>
+          </a:prstGeom>
+          <a:noFill/>
+        </p:spPr>
+        <p:txBody>
+          <a:bodyPr wrap="none">
+            <a:spAutoFit/>
+          </a:bodyPr>
+          <a:lstStyle/>
+          <a:p>
+            <a:pPr algn="l"/>
+            <a:r>
+              <a:rPr sz="1300" b="0">
+                <a:solidFill>
+                  <a:srgbClr val="FFFFFF"/>
+                </a:solidFill>
+                <a:latin typeface="Arial"/>
+              </a:rPr>
+              <a:t>leasing@levylegacygroup.com</a:t>
+            </a:r>
+          </a:p>
+        </p:txBody>
+      </p:sp>
+      <p:sp>
+        <p:nvSpPr>
+          <p:cNvPr id="37" name="TextBox 36"/>
+          <p:cNvSpPr txBox="1"/>
+          <p:nvPr/>
+        </p:nvSpPr>
+        <p:spPr>
+          <a:xfrm>
+            <a:off x="6934200" y="9886950"/>
+            <a:ext cx="7620000" cy="171450"/>
+          </a:xfrm>
+          <a:prstGeom prst="rect">
+            <a:avLst/>
+          </a:prstGeom>
+          <a:noFill/>
+        </p:spPr>
+        <p:txBody>
+          <a:bodyPr wrap="none">
+            <a:spAutoFit/>
+          </a:bodyPr>
+          <a:lstStyle/>
+          <a:p>
+            <a:pPr algn="l"/>
+            <a:r>
+              <a:rPr sz="650" b="0">
                 <a:solidFill>
                   <a:srgbClr val="607090"/>
                 </a:solidFill>

</xml_diff>